<commit_message>
adding p-values to make reviewer happy :)
</commit_message>
<xml_diff>
--- a/Figures/figure_03.pptx
+++ b/Figures/figure_03.pptx
@@ -115,7 +115,7 @@
 <file path=ppt/revisionInfo.xml><?xml version="1.0" encoding="utf-8"?>
 <p1510:revInfo xmlns:a="http://schemas.openxmlformats.org/drawingml/2006/main" xmlns:r="http://schemas.openxmlformats.org/officeDocument/2006/relationships" xmlns:p1510="http://schemas.microsoft.com/office/powerpoint/2015/10/main">
   <p1510:revLst>
-    <p1510:client id="{3E41471C-D4AE-4970-B937-938CFA670B77}" v="2" dt="2025-07-01T18:33:09.891"/>
+    <p1510:client id="{C37A6BDC-F0BB-46B2-BE86-E694FFD4FAA4}" v="14" dt="2025-12-11T15:37:08.495"/>
   </p1510:revLst>
 </p1510:revInfo>
 </file>
@@ -123,164 +123,100 @@
 <file path=ppt/changesInfos/changesInfo1.xml><?xml version="1.0" encoding="utf-8"?>
 <pc:chgInfo xmlns:a="http://schemas.openxmlformats.org/drawingml/2006/main" xmlns:r="http://schemas.openxmlformats.org/officeDocument/2006/relationships" xmlns:ac="http://schemas.microsoft.com/office/drawing/2013/main/command" xmlns:pc="http://schemas.microsoft.com/office/powerpoint/2013/main/command">
   <pc:docChgLst>
-    <pc:chgData name="Gilbert, Neil" userId="37be9f5c-8f28-415b-96d6-624acf93bb3f" providerId="ADAL" clId="{3E41471C-D4AE-4970-B937-938CFA670B77}"/>
+    <pc:chgData name="Gilbert, Neil" userId="37be9f5c-8f28-415b-96d6-624acf93bb3f" providerId="ADAL" clId="{18ED56B6-1921-416C-9A28-3F6F3C8390B5}"/>
     <pc:docChg chg="undo custSel modSld">
-      <pc:chgData name="Gilbert, Neil" userId="37be9f5c-8f28-415b-96d6-624acf93bb3f" providerId="ADAL" clId="{3E41471C-D4AE-4970-B937-938CFA670B77}" dt="2025-07-01T18:34:35.882" v="55" actId="2085"/>
+      <pc:chgData name="Gilbert, Neil" userId="37be9f5c-8f28-415b-96d6-624acf93bb3f" providerId="ADAL" clId="{18ED56B6-1921-416C-9A28-3F6F3C8390B5}" dt="2025-12-11T15:42:53.739" v="149" actId="1076"/>
       <pc:docMkLst>
         <pc:docMk/>
       </pc:docMkLst>
       <pc:sldChg chg="addSp delSp modSp mod">
-        <pc:chgData name="Gilbert, Neil" userId="37be9f5c-8f28-415b-96d6-624acf93bb3f" providerId="ADAL" clId="{3E41471C-D4AE-4970-B937-938CFA670B77}" dt="2025-07-01T18:34:35.882" v="55" actId="2085"/>
+        <pc:chgData name="Gilbert, Neil" userId="37be9f5c-8f28-415b-96d6-624acf93bb3f" providerId="ADAL" clId="{18ED56B6-1921-416C-9A28-3F6F3C8390B5}" dt="2025-12-11T15:42:53.739" v="149" actId="1076"/>
         <pc:sldMkLst>
           <pc:docMk/>
           <pc:sldMk cId="755672297" sldId="256"/>
         </pc:sldMkLst>
         <pc:spChg chg="add mod">
-          <ac:chgData name="Gilbert, Neil" userId="37be9f5c-8f28-415b-96d6-624acf93bb3f" providerId="ADAL" clId="{3E41471C-D4AE-4970-B937-938CFA670B77}" dt="2025-07-01T18:34:35.882" v="55" actId="2085"/>
+          <ac:chgData name="Gilbert, Neil" userId="37be9f5c-8f28-415b-96d6-624acf93bb3f" providerId="ADAL" clId="{18ED56B6-1921-416C-9A28-3F6F3C8390B5}" dt="2025-12-11T14:53:14.767" v="9" actId="1076"/>
+          <ac:spMkLst>
+            <pc:docMk/>
+            <pc:sldMk cId="755672297" sldId="256"/>
+            <ac:spMk id="3" creationId="{29B1786E-DB3B-8E11-AE2A-2CF0E128918B}"/>
+          </ac:spMkLst>
+        </pc:spChg>
+        <pc:spChg chg="add mod">
+          <ac:chgData name="Gilbert, Neil" userId="37be9f5c-8f28-415b-96d6-624acf93bb3f" providerId="ADAL" clId="{18ED56B6-1921-416C-9A28-3F6F3C8390B5}" dt="2025-12-11T15:39:00.900" v="129" actId="207"/>
+          <ac:spMkLst>
+            <pc:docMk/>
+            <pc:sldMk cId="755672297" sldId="256"/>
+            <ac:spMk id="5" creationId="{C972BC6D-28C0-31AD-0895-FB07026EA6A9}"/>
+          </ac:spMkLst>
+        </pc:spChg>
+        <pc:spChg chg="ord">
+          <ac:chgData name="Gilbert, Neil" userId="37be9f5c-8f28-415b-96d6-624acf93bb3f" providerId="ADAL" clId="{18ED56B6-1921-416C-9A28-3F6F3C8390B5}" dt="2025-12-11T15:42:49.077" v="148" actId="166"/>
           <ac:spMkLst>
             <pc:docMk/>
             <pc:sldMk cId="755672297" sldId="256"/>
             <ac:spMk id="7" creationId="{4B50D599-479B-F819-01A8-8622EE24BB7A}"/>
           </ac:spMkLst>
         </pc:spChg>
-        <pc:picChg chg="add mod">
-          <ac:chgData name="Gilbert, Neil" userId="37be9f5c-8f28-415b-96d6-624acf93bb3f" providerId="ADAL" clId="{3E41471C-D4AE-4970-B937-938CFA670B77}" dt="2025-07-01T18:32:46.668" v="6" actId="1076"/>
-          <ac:picMkLst>
-            <pc:docMk/>
-            <pc:sldMk cId="755672297" sldId="256"/>
-            <ac:picMk id="4" creationId="{3B6EB3A4-C645-759C-AD3C-71E548808CA0}"/>
-          </ac:picMkLst>
-        </pc:picChg>
-        <pc:picChg chg="add mod">
-          <ac:chgData name="Gilbert, Neil" userId="37be9f5c-8f28-415b-96d6-624acf93bb3f" providerId="ADAL" clId="{3E41471C-D4AE-4970-B937-938CFA670B77}" dt="2025-07-01T18:33:15.215" v="11" actId="1076"/>
-          <ac:picMkLst>
-            <pc:docMk/>
-            <pc:sldMk cId="755672297" sldId="256"/>
-            <ac:picMk id="6" creationId="{1C8FFB07-4211-3E7E-D78D-9B9AC03C435D}"/>
-          </ac:picMkLst>
-        </pc:picChg>
-        <pc:picChg chg="del">
-          <ac:chgData name="Gilbert, Neil" userId="37be9f5c-8f28-415b-96d6-624acf93bb3f" providerId="ADAL" clId="{3E41471C-D4AE-4970-B937-938CFA670B77}" dt="2025-07-01T18:33:07.070" v="7" actId="478"/>
-          <ac:picMkLst>
-            <pc:docMk/>
-            <pc:sldMk cId="755672297" sldId="256"/>
-            <ac:picMk id="9" creationId="{6672AED3-44AD-5A81-08E3-2CA6686A87C2}"/>
-          </ac:picMkLst>
-        </pc:picChg>
-        <pc:picChg chg="add del">
-          <ac:chgData name="Gilbert, Neil" userId="37be9f5c-8f28-415b-96d6-624acf93bb3f" providerId="ADAL" clId="{3E41471C-D4AE-4970-B937-938CFA670B77}" dt="2025-07-01T18:32:39.788" v="2" actId="478"/>
-          <ac:picMkLst>
-            <pc:docMk/>
-            <pc:sldMk cId="755672297" sldId="256"/>
-            <ac:picMk id="12" creationId="{E4A29A12-E68E-9A0B-6154-2EF8FB126C93}"/>
-          </ac:picMkLst>
-        </pc:picChg>
-      </pc:sldChg>
-    </pc:docChg>
-  </pc:docChgLst>
-  <pc:docChgLst>
-    <pc:chgData name="Gilbert, Neil" userId="37be9f5c-8f28-415b-96d6-624acf93bb3f" providerId="ADAL" clId="{054642A3-1F0D-4A2B-A624-50C5289E381E}"/>
-    <pc:docChg chg="undo custSel modSld">
-      <pc:chgData name="Gilbert, Neil" userId="37be9f5c-8f28-415b-96d6-624acf93bb3f" providerId="ADAL" clId="{054642A3-1F0D-4A2B-A624-50C5289E381E}" dt="2025-05-14T16:50:40.511" v="99" actId="1076"/>
-      <pc:docMkLst>
-        <pc:docMk/>
-      </pc:docMkLst>
-      <pc:sldChg chg="addSp delSp modSp mod">
-        <pc:chgData name="Gilbert, Neil" userId="37be9f5c-8f28-415b-96d6-624acf93bb3f" providerId="ADAL" clId="{054642A3-1F0D-4A2B-A624-50C5289E381E}" dt="2025-05-14T16:50:40.511" v="99" actId="1076"/>
-        <pc:sldMkLst>
-          <pc:docMk/>
-          <pc:sldMk cId="755672297" sldId="256"/>
-        </pc:sldMkLst>
-        <pc:spChg chg="ord">
-          <ac:chgData name="Gilbert, Neil" userId="37be9f5c-8f28-415b-96d6-624acf93bb3f" providerId="ADAL" clId="{054642A3-1F0D-4A2B-A624-50C5289E381E}" dt="2025-05-13T16:33:56.724" v="52" actId="167"/>
+        <pc:spChg chg="add mod">
+          <ac:chgData name="Gilbert, Neil" userId="37be9f5c-8f28-415b-96d6-624acf93bb3f" providerId="ADAL" clId="{18ED56B6-1921-416C-9A28-3F6F3C8390B5}" dt="2025-12-11T14:54:22.738" v="29" actId="1076"/>
           <ac:spMkLst>
             <pc:docMk/>
             <pc:sldMk cId="755672297" sldId="256"/>
-            <ac:spMk id="10" creationId="{42DDEB34-3673-5F43-FF66-DDD7BECBC458}"/>
+            <ac:spMk id="8" creationId="{4AEC144C-3924-93BF-509D-5E1B159C3A11}"/>
           </ac:spMkLst>
         </pc:spChg>
-        <pc:spChg chg="mod ord">
-          <ac:chgData name="Gilbert, Neil" userId="37be9f5c-8f28-415b-96d6-624acf93bb3f" providerId="ADAL" clId="{054642A3-1F0D-4A2B-A624-50C5289E381E}" dt="2025-05-14T16:47:47.594" v="65" actId="167"/>
+        <pc:spChg chg="add mod">
+          <ac:chgData name="Gilbert, Neil" userId="37be9f5c-8f28-415b-96d6-624acf93bb3f" providerId="ADAL" clId="{18ED56B6-1921-416C-9A28-3F6F3C8390B5}" dt="2025-12-11T15:42:16.631" v="143" actId="1076"/>
           <ac:spMkLst>
             <pc:docMk/>
             <pc:sldMk cId="755672297" sldId="256"/>
-            <ac:spMk id="11" creationId="{874B5DC4-89A6-C563-D409-800469FB88F1}"/>
+            <ac:spMk id="9" creationId="{8BC295CF-92B9-6874-9FEE-50656EAE389B}"/>
           </ac:spMkLst>
         </pc:spChg>
-        <pc:spChg chg="ord">
-          <ac:chgData name="Gilbert, Neil" userId="37be9f5c-8f28-415b-96d6-624acf93bb3f" providerId="ADAL" clId="{054642A3-1F0D-4A2B-A624-50C5289E381E}" dt="2025-05-13T16:33:56.724" v="52" actId="167"/>
+        <pc:spChg chg="add mod">
+          <ac:chgData name="Gilbert, Neil" userId="37be9f5c-8f28-415b-96d6-624acf93bb3f" providerId="ADAL" clId="{18ED56B6-1921-416C-9A28-3F6F3C8390B5}" dt="2025-12-11T15:41:32.117" v="136" actId="1076"/>
           <ac:spMkLst>
             <pc:docMk/>
             <pc:sldMk cId="755672297" sldId="256"/>
-            <ac:spMk id="14" creationId="{9130AA8F-4900-CF33-FAE1-277864BA731B}"/>
+            <ac:spMk id="12" creationId="{298CA453-F773-98A6-F16A-E6B55B8176CE}"/>
           </ac:spMkLst>
         </pc:spChg>
-        <pc:spChg chg="mod ord">
-          <ac:chgData name="Gilbert, Neil" userId="37be9f5c-8f28-415b-96d6-624acf93bb3f" providerId="ADAL" clId="{054642A3-1F0D-4A2B-A624-50C5289E381E}" dt="2025-05-14T16:47:47.594" v="65" actId="167"/>
+        <pc:spChg chg="add mod">
+          <ac:chgData name="Gilbert, Neil" userId="37be9f5c-8f28-415b-96d6-624acf93bb3f" providerId="ADAL" clId="{18ED56B6-1921-416C-9A28-3F6F3C8390B5}" dt="2025-12-11T15:38:03.918" v="119" actId="1076"/>
           <ac:spMkLst>
             <pc:docMk/>
             <pc:sldMk cId="755672297" sldId="256"/>
-            <ac:spMk id="17" creationId="{265DBDC5-8A87-F021-72A7-99600B0D61AD}"/>
+            <ac:spMk id="13" creationId="{8BD61F72-77AB-E206-AF12-E1803864EB7F}"/>
           </ac:spMkLst>
         </pc:spChg>
-        <pc:spChg chg="mod ord">
-          <ac:chgData name="Gilbert, Neil" userId="37be9f5c-8f28-415b-96d6-624acf93bb3f" providerId="ADAL" clId="{054642A3-1F0D-4A2B-A624-50C5289E381E}" dt="2025-05-14T16:47:47.594" v="65" actId="167"/>
+        <pc:spChg chg="add mod">
+          <ac:chgData name="Gilbert, Neil" userId="37be9f5c-8f28-415b-96d6-624acf93bb3f" providerId="ADAL" clId="{18ED56B6-1921-416C-9A28-3F6F3C8390B5}" dt="2025-12-11T15:42:01.658" v="141" actId="1076"/>
           <ac:spMkLst>
             <pc:docMk/>
             <pc:sldMk cId="755672297" sldId="256"/>
-            <ac:spMk id="18" creationId="{023A4DC2-6B3B-03AF-5F58-AAA58C8B990B}"/>
+            <ac:spMk id="15" creationId="{EE9AC9D5-6C40-1FE8-E495-1CDFFF52722A}"/>
           </ac:spMkLst>
         </pc:spChg>
-        <pc:spChg chg="mod ord">
-          <ac:chgData name="Gilbert, Neil" userId="37be9f5c-8f28-415b-96d6-624acf93bb3f" providerId="ADAL" clId="{054642A3-1F0D-4A2B-A624-50C5289E381E}" dt="2025-05-14T16:47:47.594" v="65" actId="167"/>
+        <pc:spChg chg="add mod">
+          <ac:chgData name="Gilbert, Neil" userId="37be9f5c-8f28-415b-96d6-624acf93bb3f" providerId="ADAL" clId="{18ED56B6-1921-416C-9A28-3F6F3C8390B5}" dt="2025-12-11T15:26:47.676" v="74" actId="207"/>
           <ac:spMkLst>
             <pc:docMk/>
             <pc:sldMk cId="755672297" sldId="256"/>
-            <ac:spMk id="19" creationId="{0D1FF500-7116-DB58-189D-095911D35445}"/>
+            <ac:spMk id="16" creationId="{E390D84A-0F3B-7E23-FB60-859A84F648F4}"/>
           </ac:spMkLst>
         </pc:spChg>
-        <pc:spChg chg="mod ord">
-          <ac:chgData name="Gilbert, Neil" userId="37be9f5c-8f28-415b-96d6-624acf93bb3f" providerId="ADAL" clId="{054642A3-1F0D-4A2B-A624-50C5289E381E}" dt="2025-05-14T16:47:47.594" v="65" actId="167"/>
+        <pc:spChg chg="add mod">
+          <ac:chgData name="Gilbert, Neil" userId="37be9f5c-8f28-415b-96d6-624acf93bb3f" providerId="ADAL" clId="{18ED56B6-1921-416C-9A28-3F6F3C8390B5}" dt="2025-12-11T15:42:21.308" v="144" actId="1076"/>
           <ac:spMkLst>
             <pc:docMk/>
             <pc:sldMk cId="755672297" sldId="256"/>
-            <ac:spMk id="20" creationId="{5F26E2F3-78FF-6F07-5DB0-581F3C5261FB}"/>
-          </ac:spMkLst>
-        </pc:spChg>
-        <pc:spChg chg="mod ord">
-          <ac:chgData name="Gilbert, Neil" userId="37be9f5c-8f28-415b-96d6-624acf93bb3f" providerId="ADAL" clId="{054642A3-1F0D-4A2B-A624-50C5289E381E}" dt="2025-05-14T16:47:47.594" v="65" actId="167"/>
-          <ac:spMkLst>
-            <pc:docMk/>
-            <pc:sldMk cId="755672297" sldId="256"/>
-            <ac:spMk id="21" creationId="{31FC7993-FB3A-33B6-8E28-6765FADEAC7D}"/>
-          </ac:spMkLst>
-        </pc:spChg>
-        <pc:spChg chg="mod ord">
-          <ac:chgData name="Gilbert, Neil" userId="37be9f5c-8f28-415b-96d6-624acf93bb3f" providerId="ADAL" clId="{054642A3-1F0D-4A2B-A624-50C5289E381E}" dt="2025-05-14T16:47:47.594" v="65" actId="167"/>
-          <ac:spMkLst>
-            <pc:docMk/>
-            <pc:sldMk cId="755672297" sldId="256"/>
-            <ac:spMk id="22" creationId="{75AF22DE-E1A6-F0F2-DBB6-6D70D2648CE0}"/>
-          </ac:spMkLst>
-        </pc:spChg>
-        <pc:spChg chg="mod ord">
-          <ac:chgData name="Gilbert, Neil" userId="37be9f5c-8f28-415b-96d6-624acf93bb3f" providerId="ADAL" clId="{054642A3-1F0D-4A2B-A624-50C5289E381E}" dt="2025-05-14T16:47:47.594" v="65" actId="167"/>
-          <ac:spMkLst>
-            <pc:docMk/>
-            <pc:sldMk cId="755672297" sldId="256"/>
-            <ac:spMk id="23" creationId="{3415AEF7-7A57-9BDA-362D-2717F7F01ABB}"/>
+            <ac:spMk id="24" creationId="{3B20E2D3-94B4-1731-0E88-44AEBEF499FE}"/>
           </ac:spMkLst>
         </pc:spChg>
         <pc:spChg chg="mod">
-          <ac:chgData name="Gilbert, Neil" userId="37be9f5c-8f28-415b-96d6-624acf93bb3f" providerId="ADAL" clId="{054642A3-1F0D-4A2B-A624-50C5289E381E}" dt="2025-05-12T22:07:04.751" v="7" actId="1076"/>
-          <ac:spMkLst>
-            <pc:docMk/>
-            <pc:sldMk cId="755672297" sldId="256"/>
-            <ac:spMk id="26" creationId="{CB7E50C5-0710-02E7-CA98-2D81C8EFDC9C}"/>
-          </ac:spMkLst>
-        </pc:spChg>
-        <pc:spChg chg="mod">
-          <ac:chgData name="Gilbert, Neil" userId="37be9f5c-8f28-415b-96d6-624acf93bb3f" providerId="ADAL" clId="{054642A3-1F0D-4A2B-A624-50C5289E381E}" dt="2025-05-14T16:47:57.159" v="66" actId="1076"/>
+          <ac:chgData name="Gilbert, Neil" userId="37be9f5c-8f28-415b-96d6-624acf93bb3f" providerId="ADAL" clId="{18ED56B6-1921-416C-9A28-3F6F3C8390B5}" dt="2025-12-11T15:38:48.904" v="128" actId="1076"/>
           <ac:spMkLst>
             <pc:docMk/>
             <pc:sldMk cId="755672297" sldId="256"/>
@@ -288,125 +224,61 @@
           </ac:spMkLst>
         </pc:spChg>
         <pc:spChg chg="mod">
-          <ac:chgData name="Gilbert, Neil" userId="37be9f5c-8f28-415b-96d6-624acf93bb3f" providerId="ADAL" clId="{054642A3-1F0D-4A2B-A624-50C5289E381E}" dt="2025-05-14T16:48:57.437" v="88" actId="1076"/>
+          <ac:chgData name="Gilbert, Neil" userId="37be9f5c-8f28-415b-96d6-624acf93bb3f" providerId="ADAL" clId="{18ED56B6-1921-416C-9A28-3F6F3C8390B5}" dt="2025-12-11T15:38:44.771" v="127" actId="1076"/>
           <ac:spMkLst>
             <pc:docMk/>
             <pc:sldMk cId="755672297" sldId="256"/>
             <ac:spMk id="28" creationId="{1906362E-AD5A-C8A8-170B-6087E5ED7DA2}"/>
           </ac:spMkLst>
         </pc:spChg>
-        <pc:spChg chg="mod">
-          <ac:chgData name="Gilbert, Neil" userId="37be9f5c-8f28-415b-96d6-624acf93bb3f" providerId="ADAL" clId="{054642A3-1F0D-4A2B-A624-50C5289E381E}" dt="2025-05-14T16:48:50.836" v="87" actId="1076"/>
+        <pc:spChg chg="add mod">
+          <ac:chgData name="Gilbert, Neil" userId="37be9f5c-8f28-415b-96d6-624acf93bb3f" providerId="ADAL" clId="{18ED56B6-1921-416C-9A28-3F6F3C8390B5}" dt="2025-12-11T15:42:05.858" v="142" actId="1076"/>
           <ac:spMkLst>
             <pc:docMk/>
             <pc:sldMk cId="755672297" sldId="256"/>
-            <ac:spMk id="29" creationId="{C32BB3CE-D4D8-3295-50AF-EA7140CEA405}"/>
+            <ac:spMk id="31" creationId="{5BE1FFFB-91E3-88C9-D2EA-EB86A9C709EA}"/>
           </ac:spMkLst>
         </pc:spChg>
-        <pc:spChg chg="mod">
-          <ac:chgData name="Gilbert, Neil" userId="37be9f5c-8f28-415b-96d6-624acf93bb3f" providerId="ADAL" clId="{054642A3-1F0D-4A2B-A624-50C5289E381E}" dt="2025-05-14T16:48:28.507" v="73" actId="1076"/>
+        <pc:spChg chg="add mod">
+          <ac:chgData name="Gilbert, Neil" userId="37be9f5c-8f28-415b-96d6-624acf93bb3f" providerId="ADAL" clId="{18ED56B6-1921-416C-9A28-3F6F3C8390B5}" dt="2025-12-11T15:41:37.729" v="137" actId="1076"/>
           <ac:spMkLst>
             <pc:docMk/>
             <pc:sldMk cId="755672297" sldId="256"/>
-            <ac:spMk id="30" creationId="{C3B9CDF5-109B-12BA-5577-E049A6BA041F}"/>
+            <ac:spMk id="38" creationId="{E785E38A-2EC7-5DA6-D59B-868DECA56F66}"/>
           </ac:spMkLst>
         </pc:spChg>
-        <pc:spChg chg="mod">
-          <ac:chgData name="Gilbert, Neil" userId="37be9f5c-8f28-415b-96d6-624acf93bb3f" providerId="ADAL" clId="{054642A3-1F0D-4A2B-A624-50C5289E381E}" dt="2025-05-14T16:48:21.749" v="72" actId="1076"/>
+        <pc:spChg chg="add mod">
+          <ac:chgData name="Gilbert, Neil" userId="37be9f5c-8f28-415b-96d6-624acf93bb3f" providerId="ADAL" clId="{18ED56B6-1921-416C-9A28-3F6F3C8390B5}" dt="2025-12-11T15:42:25.786" v="145" actId="1076"/>
           <ac:spMkLst>
             <pc:docMk/>
             <pc:sldMk cId="755672297" sldId="256"/>
-            <ac:spMk id="32" creationId="{3AB453D8-5F8E-DBCD-F415-0BADDACEE160}"/>
+            <ac:spMk id="39" creationId="{4ADCFA41-24CB-4B62-5250-DEA51EB88B3A}"/>
           </ac:spMkLst>
         </pc:spChg>
-        <pc:spChg chg="mod">
-          <ac:chgData name="Gilbert, Neil" userId="37be9f5c-8f28-415b-96d6-624acf93bb3f" providerId="ADAL" clId="{054642A3-1F0D-4A2B-A624-50C5289E381E}" dt="2025-05-13T16:23:54.303" v="39" actId="1076"/>
+        <pc:spChg chg="add mod">
+          <ac:chgData name="Gilbert, Neil" userId="37be9f5c-8f28-415b-96d6-624acf93bb3f" providerId="ADAL" clId="{18ED56B6-1921-416C-9A28-3F6F3C8390B5}" dt="2025-12-11T15:41:47.569" v="140" actId="1076"/>
           <ac:spMkLst>
             <pc:docMk/>
             <pc:sldMk cId="755672297" sldId="256"/>
-            <ac:spMk id="33" creationId="{121077E8-6BFE-2D1F-8C2C-131DCCD540FC}"/>
+            <ac:spMk id="47" creationId="{BEB3E9F4-0F7B-28F8-051E-8A0ED629D4CB}"/>
           </ac:spMkLst>
         </pc:spChg>
-        <pc:spChg chg="mod">
-          <ac:chgData name="Gilbert, Neil" userId="37be9f5c-8f28-415b-96d6-624acf93bb3f" providerId="ADAL" clId="{054642A3-1F0D-4A2B-A624-50C5289E381E}" dt="2025-05-13T16:23:57.607" v="40" actId="1076"/>
-          <ac:spMkLst>
-            <pc:docMk/>
-            <pc:sldMk cId="755672297" sldId="256"/>
-            <ac:spMk id="35" creationId="{5D65B3A6-A108-00F9-7092-B321944CC5A1}"/>
-          </ac:spMkLst>
-        </pc:spChg>
-        <pc:spChg chg="mod">
-          <ac:chgData name="Gilbert, Neil" userId="37be9f5c-8f28-415b-96d6-624acf93bb3f" providerId="ADAL" clId="{054642A3-1F0D-4A2B-A624-50C5289E381E}" dt="2025-05-13T16:24:01.898" v="41" actId="1076"/>
-          <ac:spMkLst>
-            <pc:docMk/>
-            <pc:sldMk cId="755672297" sldId="256"/>
-            <ac:spMk id="36" creationId="{FA2AE00B-ED9F-AAF1-5C5F-2BF85ABD78A3}"/>
-          </ac:spMkLst>
-        </pc:spChg>
-        <pc:spChg chg="mod">
-          <ac:chgData name="Gilbert, Neil" userId="37be9f5c-8f28-415b-96d6-624acf93bb3f" providerId="ADAL" clId="{054642A3-1F0D-4A2B-A624-50C5289E381E}" dt="2025-05-13T16:24:06.428" v="42" actId="1076"/>
-          <ac:spMkLst>
-            <pc:docMk/>
-            <pc:sldMk cId="755672297" sldId="256"/>
-            <ac:spMk id="37" creationId="{82AF4F38-FC39-E880-A3D8-585288FAB280}"/>
-          </ac:spMkLst>
-        </pc:spChg>
-        <pc:spChg chg="mod">
-          <ac:chgData name="Gilbert, Neil" userId="37be9f5c-8f28-415b-96d6-624acf93bb3f" providerId="ADAL" clId="{054642A3-1F0D-4A2B-A624-50C5289E381E}" dt="2025-05-13T16:24:12.423" v="43" actId="1076"/>
-          <ac:spMkLst>
-            <pc:docMk/>
-            <pc:sldMk cId="755672297" sldId="256"/>
-            <ac:spMk id="41" creationId="{EB73DF97-6630-914B-BF05-0473CDD6EBDC}"/>
-          </ac:spMkLst>
-        </pc:spChg>
-        <pc:spChg chg="mod">
-          <ac:chgData name="Gilbert, Neil" userId="37be9f5c-8f28-415b-96d6-624acf93bb3f" providerId="ADAL" clId="{054642A3-1F0D-4A2B-A624-50C5289E381E}" dt="2025-05-13T16:24:15.554" v="44" actId="1076"/>
-          <ac:spMkLst>
-            <pc:docMk/>
-            <pc:sldMk cId="755672297" sldId="256"/>
-            <ac:spMk id="42" creationId="{B75475DC-F91D-B155-96E8-28C0B982BE2D}"/>
-          </ac:spMkLst>
-        </pc:spChg>
-        <pc:spChg chg="mod">
-          <ac:chgData name="Gilbert, Neil" userId="37be9f5c-8f28-415b-96d6-624acf93bb3f" providerId="ADAL" clId="{054642A3-1F0D-4A2B-A624-50C5289E381E}" dt="2025-05-14T16:49:13.549" v="89" actId="207"/>
-          <ac:spMkLst>
-            <pc:docMk/>
-            <pc:sldMk cId="755672297" sldId="256"/>
-            <ac:spMk id="45" creationId="{FF59B477-52FB-BFE6-F813-597B4705F43F}"/>
-          </ac:spMkLst>
-        </pc:spChg>
-        <pc:spChg chg="mod">
-          <ac:chgData name="Gilbert, Neil" userId="37be9f5c-8f28-415b-96d6-624acf93bb3f" providerId="ADAL" clId="{054642A3-1F0D-4A2B-A624-50C5289E381E}" dt="2025-05-13T16:34:07.446" v="54" actId="1076"/>
-          <ac:spMkLst>
-            <pc:docMk/>
-            <pc:sldMk cId="755672297" sldId="256"/>
-            <ac:spMk id="56" creationId="{A97736DA-86DE-6C79-5DA3-926CA941B2F0}"/>
-          </ac:spMkLst>
-        </pc:spChg>
-        <pc:picChg chg="add mod">
-          <ac:chgData name="Gilbert, Neil" userId="37be9f5c-8f28-415b-96d6-624acf93bb3f" providerId="ADAL" clId="{054642A3-1F0D-4A2B-A624-50C5289E381E}" dt="2025-05-14T16:50:40.511" v="99" actId="1076"/>
+        <pc:picChg chg="add del ord">
+          <ac:chgData name="Gilbert, Neil" userId="37be9f5c-8f28-415b-96d6-624acf93bb3f" providerId="ADAL" clId="{18ED56B6-1921-416C-9A28-3F6F3C8390B5}" dt="2025-12-11T14:53:34.578" v="14" actId="166"/>
           <ac:picMkLst>
             <pc:docMk/>
             <pc:sldMk cId="755672297" sldId="256"/>
-            <ac:picMk id="9" creationId="{6672AED3-44AD-5A81-08E3-2CA6686A87C2}"/>
+            <ac:picMk id="4" creationId="{3B6EB3A4-C645-759C-AD3C-71E548808CA0}"/>
           </ac:picMkLst>
         </pc:picChg>
-        <pc:cxnChg chg="add mod">
-          <ac:chgData name="Gilbert, Neil" userId="37be9f5c-8f28-415b-96d6-624acf93bb3f" providerId="ADAL" clId="{054642A3-1F0D-4A2B-A624-50C5289E381E}" dt="2025-05-12T22:07:00.615" v="6" actId="1076"/>
-          <ac:cxnSpMkLst>
+        <pc:picChg chg="mod ord">
+          <ac:chgData name="Gilbert, Neil" userId="37be9f5c-8f28-415b-96d6-624acf93bb3f" providerId="ADAL" clId="{18ED56B6-1921-416C-9A28-3F6F3C8390B5}" dt="2025-12-11T15:42:53.739" v="149" actId="1076"/>
+          <ac:picMkLst>
             <pc:docMk/>
             <pc:sldMk cId="755672297" sldId="256"/>
-            <ac:cxnSpMk id="2" creationId="{EA2E7AFA-9762-A8E3-A6AC-BE3F91C4D2F5}"/>
-          </ac:cxnSpMkLst>
-        </pc:cxnChg>
-        <pc:cxnChg chg="mod">
-          <ac:chgData name="Gilbert, Neil" userId="37be9f5c-8f28-415b-96d6-624acf93bb3f" providerId="ADAL" clId="{054642A3-1F0D-4A2B-A624-50C5289E381E}" dt="2025-05-13T16:34:02.058" v="53" actId="1076"/>
-          <ac:cxnSpMkLst>
-            <pc:docMk/>
-            <pc:sldMk cId="755672297" sldId="256"/>
-            <ac:cxnSpMk id="52" creationId="{621F9ACA-828F-A3D1-2FC6-4162C29B0A5C}"/>
-          </ac:cxnSpMkLst>
-        </pc:cxnChg>
+            <ac:picMk id="6" creationId="{1C8FFB07-4211-3E7E-D78D-9B9AC03C435D}"/>
+          </ac:picMkLst>
+        </pc:picChg>
       </pc:sldChg>
     </pc:docChg>
   </pc:docChgLst>
@@ -544,7 +416,7 @@
           <a:p>
             <a:fld id="{59AD73E6-7E75-4E39-938D-6446E26014F1}" type="datetimeFigureOut">
               <a:rPr lang="en-US" smtClean="0"/>
-              <a:t>7/1/2025</a:t>
+              <a:t>12/11/2025</a:t>
             </a:fld>
             <a:endParaRPr lang="en-US"/>
           </a:p>
@@ -714,7 +586,7 @@
           <a:p>
             <a:fld id="{59AD73E6-7E75-4E39-938D-6446E26014F1}" type="datetimeFigureOut">
               <a:rPr lang="en-US" smtClean="0"/>
-              <a:t>7/1/2025</a:t>
+              <a:t>12/11/2025</a:t>
             </a:fld>
             <a:endParaRPr lang="en-US"/>
           </a:p>
@@ -894,7 +766,7 @@
           <a:p>
             <a:fld id="{59AD73E6-7E75-4E39-938D-6446E26014F1}" type="datetimeFigureOut">
               <a:rPr lang="en-US" smtClean="0"/>
-              <a:t>7/1/2025</a:t>
+              <a:t>12/11/2025</a:t>
             </a:fld>
             <a:endParaRPr lang="en-US"/>
           </a:p>
@@ -1064,7 +936,7 @@
           <a:p>
             <a:fld id="{59AD73E6-7E75-4E39-938D-6446E26014F1}" type="datetimeFigureOut">
               <a:rPr lang="en-US" smtClean="0"/>
-              <a:t>7/1/2025</a:t>
+              <a:t>12/11/2025</a:t>
             </a:fld>
             <a:endParaRPr lang="en-US"/>
           </a:p>
@@ -1310,7 +1182,7 @@
           <a:p>
             <a:fld id="{59AD73E6-7E75-4E39-938D-6446E26014F1}" type="datetimeFigureOut">
               <a:rPr lang="en-US" smtClean="0"/>
-              <a:t>7/1/2025</a:t>
+              <a:t>12/11/2025</a:t>
             </a:fld>
             <a:endParaRPr lang="en-US"/>
           </a:p>
@@ -1542,7 +1414,7 @@
           <a:p>
             <a:fld id="{59AD73E6-7E75-4E39-938D-6446E26014F1}" type="datetimeFigureOut">
               <a:rPr lang="en-US" smtClean="0"/>
-              <a:t>7/1/2025</a:t>
+              <a:t>12/11/2025</a:t>
             </a:fld>
             <a:endParaRPr lang="en-US"/>
           </a:p>
@@ -1909,7 +1781,7 @@
           <a:p>
             <a:fld id="{59AD73E6-7E75-4E39-938D-6446E26014F1}" type="datetimeFigureOut">
               <a:rPr lang="en-US" smtClean="0"/>
-              <a:t>7/1/2025</a:t>
+              <a:t>12/11/2025</a:t>
             </a:fld>
             <a:endParaRPr lang="en-US"/>
           </a:p>
@@ -2027,7 +1899,7 @@
           <a:p>
             <a:fld id="{59AD73E6-7E75-4E39-938D-6446E26014F1}" type="datetimeFigureOut">
               <a:rPr lang="en-US" smtClean="0"/>
-              <a:t>7/1/2025</a:t>
+              <a:t>12/11/2025</a:t>
             </a:fld>
             <a:endParaRPr lang="en-US"/>
           </a:p>
@@ -2122,7 +1994,7 @@
           <a:p>
             <a:fld id="{59AD73E6-7E75-4E39-938D-6446E26014F1}" type="datetimeFigureOut">
               <a:rPr lang="en-US" smtClean="0"/>
-              <a:t>7/1/2025</a:t>
+              <a:t>12/11/2025</a:t>
             </a:fld>
             <a:endParaRPr lang="en-US"/>
           </a:p>
@@ -2399,7 +2271,7 @@
           <a:p>
             <a:fld id="{59AD73E6-7E75-4E39-938D-6446E26014F1}" type="datetimeFigureOut">
               <a:rPr lang="en-US" smtClean="0"/>
-              <a:t>7/1/2025</a:t>
+              <a:t>12/11/2025</a:t>
             </a:fld>
             <a:endParaRPr lang="en-US"/>
           </a:p>
@@ -2656,7 +2528,7 @@
           <a:p>
             <a:fld id="{59AD73E6-7E75-4E39-938D-6446E26014F1}" type="datetimeFigureOut">
               <a:rPr lang="en-US" smtClean="0"/>
-              <a:t>7/1/2025</a:t>
+              <a:t>12/11/2025</a:t>
             </a:fld>
             <a:endParaRPr lang="en-US"/>
           </a:p>
@@ -2869,7 +2741,7 @@
           <a:p>
             <a:fld id="{59AD73E6-7E75-4E39-938D-6446E26014F1}" type="datetimeFigureOut">
               <a:rPr lang="en-US" smtClean="0"/>
-              <a:t>7/1/2025</a:t>
+              <a:t>12/11/2025</a:t>
             </a:fld>
             <a:endParaRPr lang="en-US"/>
           </a:p>
@@ -4069,7 +3941,7 @@
         </p:nvSpPr>
         <p:spPr>
           <a:xfrm>
-            <a:off x="4007386" y="598301"/>
+            <a:off x="4608617" y="664213"/>
             <a:ext cx="376237" cy="102394"/>
           </a:xfrm>
           <a:prstGeom prst="rect">
@@ -4128,7 +4000,7 @@
         </p:nvSpPr>
         <p:spPr>
           <a:xfrm>
-            <a:off x="4612010" y="689052"/>
+            <a:off x="3946655" y="695826"/>
             <a:ext cx="376237" cy="102394"/>
           </a:xfrm>
           <a:prstGeom prst="rect">
@@ -5320,6 +5192,68 @@
           </a:fontRef>
         </p:style>
       </p:cxnSp>
+      <p:sp>
+        <p:nvSpPr>
+          <p:cNvPr id="5" name="Rectangle 4">
+            <a:extLst>
+              <a:ext uri="{FF2B5EF4-FFF2-40B4-BE49-F238E27FC236}">
+                <a16:creationId xmlns:a16="http://schemas.microsoft.com/office/drawing/2014/main" id="{C972BC6D-28C0-31AD-0895-FB07026EA6A9}"/>
+              </a:ext>
+            </a:extLst>
+          </p:cNvPr>
+          <p:cNvSpPr/>
+          <p:nvPr/>
+        </p:nvSpPr>
+        <p:spPr>
+          <a:xfrm>
+            <a:off x="3845275" y="495173"/>
+            <a:ext cx="636999" cy="144461"/>
+          </a:xfrm>
+          <a:prstGeom prst="rect">
+            <a:avLst/>
+          </a:prstGeom>
+          <a:noFill/>
+          <a:ln>
+            <a:noFill/>
+          </a:ln>
+          <a:effectLst>
+            <a:softEdge rad="0"/>
+          </a:effectLst>
+        </p:spPr>
+        <p:style>
+          <a:lnRef idx="2">
+            <a:schemeClr val="accent1">
+              <a:shade val="15000"/>
+            </a:schemeClr>
+          </a:lnRef>
+          <a:fillRef idx="1">
+            <a:schemeClr val="accent1"/>
+          </a:fillRef>
+          <a:effectRef idx="0">
+            <a:schemeClr val="accent1"/>
+          </a:effectRef>
+          <a:fontRef idx="minor">
+            <a:schemeClr val="lt1"/>
+          </a:fontRef>
+        </p:style>
+        <p:txBody>
+          <a:bodyPr lIns="0" rIns="0" rtlCol="0" anchor="ctr"/>
+          <a:lstStyle/>
+          <a:p>
+            <a:pPr algn="ctr"/>
+            <a:r>
+              <a:rPr lang="en-US" sz="700" i="1" dirty="0">
+                <a:solidFill>
+                  <a:srgbClr val="CE9642"/>
+                </a:solidFill>
+                <a:latin typeface="Arial" panose="020B0604020202020204" pitchFamily="34" charset="0"/>
+                <a:cs typeface="Arial" panose="020B0604020202020204" pitchFamily="34" charset="0"/>
+              </a:rPr>
+              <a:t>p &lt; 0.01</a:t>
+            </a:r>
+          </a:p>
+        </p:txBody>
+      </p:sp>
       <p:pic>
         <p:nvPicPr>
           <p:cNvPr id="4" name="Picture 3" descr="A blue and black background&#10;&#10;AI-generated content may be incorrect.">
@@ -5356,6 +5290,688 @@
           </a:prstGeom>
         </p:spPr>
       </p:pic>
+      <p:sp>
+        <p:nvSpPr>
+          <p:cNvPr id="8" name="Rectangle 7">
+            <a:extLst>
+              <a:ext uri="{FF2B5EF4-FFF2-40B4-BE49-F238E27FC236}">
+                <a16:creationId xmlns:a16="http://schemas.microsoft.com/office/drawing/2014/main" id="{4AEC144C-3924-93BF-509D-5E1B159C3A11}"/>
+              </a:ext>
+            </a:extLst>
+          </p:cNvPr>
+          <p:cNvSpPr/>
+          <p:nvPr/>
+        </p:nvSpPr>
+        <p:spPr>
+          <a:xfrm>
+            <a:off x="3005269" y="491929"/>
+            <a:ext cx="636999" cy="144461"/>
+          </a:xfrm>
+          <a:prstGeom prst="rect">
+            <a:avLst/>
+          </a:prstGeom>
+          <a:noFill/>
+          <a:ln>
+            <a:noFill/>
+          </a:ln>
+          <a:effectLst>
+            <a:softEdge rad="0"/>
+          </a:effectLst>
+        </p:spPr>
+        <p:style>
+          <a:lnRef idx="2">
+            <a:schemeClr val="accent1">
+              <a:shade val="15000"/>
+            </a:schemeClr>
+          </a:lnRef>
+          <a:fillRef idx="1">
+            <a:schemeClr val="accent1"/>
+          </a:fillRef>
+          <a:effectRef idx="0">
+            <a:schemeClr val="accent1"/>
+          </a:effectRef>
+          <a:fontRef idx="minor">
+            <a:schemeClr val="lt1"/>
+          </a:fontRef>
+        </p:style>
+        <p:txBody>
+          <a:bodyPr lIns="0" rIns="0" rtlCol="0" anchor="ctr"/>
+          <a:lstStyle/>
+          <a:p>
+            <a:pPr algn="ctr"/>
+            <a:r>
+              <a:rPr lang="en-US" sz="700" i="1" dirty="0">
+                <a:solidFill>
+                  <a:schemeClr val="tx1"/>
+                </a:solidFill>
+                <a:latin typeface="Arial" panose="020B0604020202020204" pitchFamily="34" charset="0"/>
+                <a:cs typeface="Arial" panose="020B0604020202020204" pitchFamily="34" charset="0"/>
+              </a:rPr>
+              <a:t>p &lt; 0.01</a:t>
+            </a:r>
+          </a:p>
+        </p:txBody>
+      </p:sp>
+      <p:sp>
+        <p:nvSpPr>
+          <p:cNvPr id="9" name="Rectangle 8">
+            <a:extLst>
+              <a:ext uri="{FF2B5EF4-FFF2-40B4-BE49-F238E27FC236}">
+                <a16:creationId xmlns:a16="http://schemas.microsoft.com/office/drawing/2014/main" id="{8BC295CF-92B9-6874-9FEE-50656EAE389B}"/>
+              </a:ext>
+            </a:extLst>
+          </p:cNvPr>
+          <p:cNvSpPr/>
+          <p:nvPr/>
+        </p:nvSpPr>
+        <p:spPr>
+          <a:xfrm>
+            <a:off x="3008376" y="1789503"/>
+            <a:ext cx="636999" cy="144461"/>
+          </a:xfrm>
+          <a:prstGeom prst="rect">
+            <a:avLst/>
+          </a:prstGeom>
+          <a:noFill/>
+          <a:ln>
+            <a:noFill/>
+          </a:ln>
+          <a:effectLst>
+            <a:softEdge rad="0"/>
+          </a:effectLst>
+        </p:spPr>
+        <p:style>
+          <a:lnRef idx="2">
+            <a:schemeClr val="accent1">
+              <a:shade val="15000"/>
+            </a:schemeClr>
+          </a:lnRef>
+          <a:fillRef idx="1">
+            <a:schemeClr val="accent1"/>
+          </a:fillRef>
+          <a:effectRef idx="0">
+            <a:schemeClr val="accent1"/>
+          </a:effectRef>
+          <a:fontRef idx="minor">
+            <a:schemeClr val="lt1"/>
+          </a:fontRef>
+        </p:style>
+        <p:txBody>
+          <a:bodyPr lIns="0" rIns="0" rtlCol="0" anchor="ctr"/>
+          <a:lstStyle/>
+          <a:p>
+            <a:pPr algn="ctr"/>
+            <a:r>
+              <a:rPr lang="en-US" sz="700" i="1" dirty="0">
+                <a:solidFill>
+                  <a:schemeClr val="tx1"/>
+                </a:solidFill>
+                <a:latin typeface="Arial" panose="020B0604020202020204" pitchFamily="34" charset="0"/>
+                <a:cs typeface="Arial" panose="020B0604020202020204" pitchFamily="34" charset="0"/>
+              </a:rPr>
+              <a:t>p &lt; 0.01</a:t>
+            </a:r>
+          </a:p>
+        </p:txBody>
+      </p:sp>
+      <p:sp>
+        <p:nvSpPr>
+          <p:cNvPr id="12" name="Rectangle 11">
+            <a:extLst>
+              <a:ext uri="{FF2B5EF4-FFF2-40B4-BE49-F238E27FC236}">
+                <a16:creationId xmlns:a16="http://schemas.microsoft.com/office/drawing/2014/main" id="{298CA453-F773-98A6-F16A-E6B55B8176CE}"/>
+              </a:ext>
+            </a:extLst>
+          </p:cNvPr>
+          <p:cNvSpPr/>
+          <p:nvPr/>
+        </p:nvSpPr>
+        <p:spPr>
+          <a:xfrm>
+            <a:off x="4553712" y="1789503"/>
+            <a:ext cx="636999" cy="144461"/>
+          </a:xfrm>
+          <a:prstGeom prst="rect">
+            <a:avLst/>
+          </a:prstGeom>
+          <a:noFill/>
+          <a:ln>
+            <a:noFill/>
+          </a:ln>
+          <a:effectLst>
+            <a:softEdge rad="0"/>
+          </a:effectLst>
+        </p:spPr>
+        <p:style>
+          <a:lnRef idx="2">
+            <a:schemeClr val="accent1">
+              <a:shade val="15000"/>
+            </a:schemeClr>
+          </a:lnRef>
+          <a:fillRef idx="1">
+            <a:schemeClr val="accent1"/>
+          </a:fillRef>
+          <a:effectRef idx="0">
+            <a:schemeClr val="accent1"/>
+          </a:effectRef>
+          <a:fontRef idx="minor">
+            <a:schemeClr val="lt1"/>
+          </a:fontRef>
+        </p:style>
+        <p:txBody>
+          <a:bodyPr lIns="0" rIns="0" rtlCol="0" anchor="ctr"/>
+          <a:lstStyle/>
+          <a:p>
+            <a:pPr algn="ctr"/>
+            <a:r>
+              <a:rPr lang="en-US" sz="700" i="1" dirty="0">
+                <a:solidFill>
+                  <a:srgbClr val="134B73"/>
+                </a:solidFill>
+                <a:latin typeface="Arial" panose="020B0604020202020204" pitchFamily="34" charset="0"/>
+                <a:cs typeface="Arial" panose="020B0604020202020204" pitchFamily="34" charset="0"/>
+              </a:rPr>
+              <a:t>p = 0.06</a:t>
+            </a:r>
+          </a:p>
+        </p:txBody>
+      </p:sp>
+      <p:sp>
+        <p:nvSpPr>
+          <p:cNvPr id="13" name="Rectangle 12">
+            <a:extLst>
+              <a:ext uri="{FF2B5EF4-FFF2-40B4-BE49-F238E27FC236}">
+                <a16:creationId xmlns:a16="http://schemas.microsoft.com/office/drawing/2014/main" id="{8BD61F72-77AB-E206-AF12-E1803864EB7F}"/>
+              </a:ext>
+            </a:extLst>
+          </p:cNvPr>
+          <p:cNvSpPr/>
+          <p:nvPr/>
+        </p:nvSpPr>
+        <p:spPr>
+          <a:xfrm>
+            <a:off x="4552636" y="495173"/>
+            <a:ext cx="636999" cy="144461"/>
+          </a:xfrm>
+          <a:prstGeom prst="rect">
+            <a:avLst/>
+          </a:prstGeom>
+          <a:noFill/>
+          <a:ln>
+            <a:noFill/>
+          </a:ln>
+          <a:effectLst>
+            <a:softEdge rad="0"/>
+          </a:effectLst>
+        </p:spPr>
+        <p:style>
+          <a:lnRef idx="2">
+            <a:schemeClr val="accent1">
+              <a:shade val="15000"/>
+            </a:schemeClr>
+          </a:lnRef>
+          <a:fillRef idx="1">
+            <a:schemeClr val="accent1"/>
+          </a:fillRef>
+          <a:effectRef idx="0">
+            <a:schemeClr val="accent1"/>
+          </a:effectRef>
+          <a:fontRef idx="minor">
+            <a:schemeClr val="lt1"/>
+          </a:fontRef>
+        </p:style>
+        <p:txBody>
+          <a:bodyPr lIns="0" rIns="0" rtlCol="0" anchor="ctr"/>
+          <a:lstStyle/>
+          <a:p>
+            <a:pPr algn="ctr"/>
+            <a:r>
+              <a:rPr lang="en-US" sz="700" i="1" dirty="0">
+                <a:solidFill>
+                  <a:srgbClr val="3B3A3E"/>
+                </a:solidFill>
+                <a:latin typeface="Arial" panose="020B0604020202020204" pitchFamily="34" charset="0"/>
+                <a:cs typeface="Arial" panose="020B0604020202020204" pitchFamily="34" charset="0"/>
+              </a:rPr>
+              <a:t>p &lt; 0.01</a:t>
+            </a:r>
+          </a:p>
+        </p:txBody>
+      </p:sp>
+      <p:sp>
+        <p:nvSpPr>
+          <p:cNvPr id="15" name="Rectangle 14">
+            <a:extLst>
+              <a:ext uri="{FF2B5EF4-FFF2-40B4-BE49-F238E27FC236}">
+                <a16:creationId xmlns:a16="http://schemas.microsoft.com/office/drawing/2014/main" id="{EE9AC9D5-6C40-1FE8-E495-1CDFFF52722A}"/>
+              </a:ext>
+            </a:extLst>
+          </p:cNvPr>
+          <p:cNvSpPr/>
+          <p:nvPr/>
+        </p:nvSpPr>
+        <p:spPr>
+          <a:xfrm>
+            <a:off x="3849624" y="1793703"/>
+            <a:ext cx="636999" cy="144461"/>
+          </a:xfrm>
+          <a:prstGeom prst="rect">
+            <a:avLst/>
+          </a:prstGeom>
+          <a:noFill/>
+          <a:ln>
+            <a:noFill/>
+          </a:ln>
+          <a:effectLst>
+            <a:softEdge rad="0"/>
+          </a:effectLst>
+        </p:spPr>
+        <p:style>
+          <a:lnRef idx="2">
+            <a:schemeClr val="accent1">
+              <a:shade val="15000"/>
+            </a:schemeClr>
+          </a:lnRef>
+          <a:fillRef idx="1">
+            <a:schemeClr val="accent1"/>
+          </a:fillRef>
+          <a:effectRef idx="0">
+            <a:schemeClr val="accent1"/>
+          </a:effectRef>
+          <a:fontRef idx="minor">
+            <a:schemeClr val="lt1"/>
+          </a:fontRef>
+        </p:style>
+        <p:txBody>
+          <a:bodyPr lIns="0" rIns="0" rtlCol="0" anchor="ctr"/>
+          <a:lstStyle/>
+          <a:p>
+            <a:pPr algn="ctr"/>
+            <a:r>
+              <a:rPr lang="en-US" sz="700" i="1" dirty="0">
+                <a:solidFill>
+                  <a:srgbClr val="72AEB6"/>
+                </a:solidFill>
+                <a:latin typeface="Arial" panose="020B0604020202020204" pitchFamily="34" charset="0"/>
+                <a:cs typeface="Arial" panose="020B0604020202020204" pitchFamily="34" charset="0"/>
+              </a:rPr>
+              <a:t>p &lt; 0.01</a:t>
+            </a:r>
+          </a:p>
+        </p:txBody>
+      </p:sp>
+      <p:sp>
+        <p:nvSpPr>
+          <p:cNvPr id="16" name="Rectangle 15">
+            <a:extLst>
+              <a:ext uri="{FF2B5EF4-FFF2-40B4-BE49-F238E27FC236}">
+                <a16:creationId xmlns:a16="http://schemas.microsoft.com/office/drawing/2014/main" id="{E390D84A-0F3B-7E23-FB60-859A84F648F4}"/>
+              </a:ext>
+            </a:extLst>
+          </p:cNvPr>
+          <p:cNvSpPr/>
+          <p:nvPr/>
+        </p:nvSpPr>
+        <p:spPr>
+          <a:xfrm>
+            <a:off x="2346427" y="3086784"/>
+            <a:ext cx="636999" cy="144461"/>
+          </a:xfrm>
+          <a:prstGeom prst="rect">
+            <a:avLst/>
+          </a:prstGeom>
+          <a:noFill/>
+          <a:ln>
+            <a:noFill/>
+          </a:ln>
+          <a:effectLst>
+            <a:softEdge rad="0"/>
+          </a:effectLst>
+        </p:spPr>
+        <p:style>
+          <a:lnRef idx="2">
+            <a:schemeClr val="accent1">
+              <a:shade val="15000"/>
+            </a:schemeClr>
+          </a:lnRef>
+          <a:fillRef idx="1">
+            <a:schemeClr val="accent1"/>
+          </a:fillRef>
+          <a:effectRef idx="0">
+            <a:schemeClr val="accent1"/>
+          </a:effectRef>
+          <a:fontRef idx="minor">
+            <a:schemeClr val="lt1"/>
+          </a:fontRef>
+        </p:style>
+        <p:txBody>
+          <a:bodyPr lIns="0" rIns="0" rtlCol="0" anchor="ctr"/>
+          <a:lstStyle/>
+          <a:p>
+            <a:pPr algn="ctr"/>
+            <a:r>
+              <a:rPr lang="en-US" sz="700" i="1" dirty="0">
+                <a:solidFill>
+                  <a:srgbClr val="90719F"/>
+                </a:solidFill>
+                <a:latin typeface="Arial" panose="020B0604020202020204" pitchFamily="34" charset="0"/>
+                <a:cs typeface="Arial" panose="020B0604020202020204" pitchFamily="34" charset="0"/>
+              </a:rPr>
+              <a:t>p = 0.02</a:t>
+            </a:r>
+          </a:p>
+        </p:txBody>
+      </p:sp>
+      <p:sp>
+        <p:nvSpPr>
+          <p:cNvPr id="24" name="Rectangle 23">
+            <a:extLst>
+              <a:ext uri="{FF2B5EF4-FFF2-40B4-BE49-F238E27FC236}">
+                <a16:creationId xmlns:a16="http://schemas.microsoft.com/office/drawing/2014/main" id="{3B20E2D3-94B4-1731-0E88-44AEBEF499FE}"/>
+              </a:ext>
+            </a:extLst>
+          </p:cNvPr>
+          <p:cNvSpPr/>
+          <p:nvPr/>
+        </p:nvSpPr>
+        <p:spPr>
+          <a:xfrm>
+            <a:off x="3008376" y="3086784"/>
+            <a:ext cx="636999" cy="144461"/>
+          </a:xfrm>
+          <a:prstGeom prst="rect">
+            <a:avLst/>
+          </a:prstGeom>
+          <a:noFill/>
+          <a:ln>
+            <a:noFill/>
+          </a:ln>
+          <a:effectLst>
+            <a:softEdge rad="0"/>
+          </a:effectLst>
+        </p:spPr>
+        <p:style>
+          <a:lnRef idx="2">
+            <a:schemeClr val="accent1">
+              <a:shade val="15000"/>
+            </a:schemeClr>
+          </a:lnRef>
+          <a:fillRef idx="1">
+            <a:schemeClr val="accent1"/>
+          </a:fillRef>
+          <a:effectRef idx="0">
+            <a:schemeClr val="accent1"/>
+          </a:effectRef>
+          <a:fontRef idx="minor">
+            <a:schemeClr val="lt1"/>
+          </a:fontRef>
+        </p:style>
+        <p:txBody>
+          <a:bodyPr lIns="0" rIns="0" rtlCol="0" anchor="ctr"/>
+          <a:lstStyle/>
+          <a:p>
+            <a:pPr algn="ctr"/>
+            <a:r>
+              <a:rPr lang="en-US" sz="700" i="1" dirty="0">
+                <a:solidFill>
+                  <a:srgbClr val="466C4B"/>
+                </a:solidFill>
+                <a:latin typeface="Arial" panose="020B0604020202020204" pitchFamily="34" charset="0"/>
+                <a:cs typeface="Arial" panose="020B0604020202020204" pitchFamily="34" charset="0"/>
+              </a:rPr>
+              <a:t>p &lt; 0.01</a:t>
+            </a:r>
+          </a:p>
+        </p:txBody>
+      </p:sp>
+      <p:sp>
+        <p:nvSpPr>
+          <p:cNvPr id="31" name="Rectangle 30">
+            <a:extLst>
+              <a:ext uri="{FF2B5EF4-FFF2-40B4-BE49-F238E27FC236}">
+                <a16:creationId xmlns:a16="http://schemas.microsoft.com/office/drawing/2014/main" id="{5BE1FFFB-91E3-88C9-D2EA-EB86A9C709EA}"/>
+              </a:ext>
+            </a:extLst>
+          </p:cNvPr>
+          <p:cNvSpPr/>
+          <p:nvPr/>
+        </p:nvSpPr>
+        <p:spPr>
+          <a:xfrm>
+            <a:off x="3849624" y="3090672"/>
+            <a:ext cx="636999" cy="144461"/>
+          </a:xfrm>
+          <a:prstGeom prst="rect">
+            <a:avLst/>
+          </a:prstGeom>
+          <a:noFill/>
+          <a:ln>
+            <a:noFill/>
+          </a:ln>
+          <a:effectLst>
+            <a:softEdge rad="0"/>
+          </a:effectLst>
+        </p:spPr>
+        <p:style>
+          <a:lnRef idx="2">
+            <a:schemeClr val="accent1">
+              <a:shade val="15000"/>
+            </a:schemeClr>
+          </a:lnRef>
+          <a:fillRef idx="1">
+            <a:schemeClr val="accent1"/>
+          </a:fillRef>
+          <a:effectRef idx="0">
+            <a:schemeClr val="accent1"/>
+          </a:effectRef>
+          <a:fontRef idx="minor">
+            <a:schemeClr val="lt1"/>
+          </a:fontRef>
+        </p:style>
+        <p:txBody>
+          <a:bodyPr lIns="0" rIns="0" rtlCol="0" anchor="ctr"/>
+          <a:lstStyle/>
+          <a:p>
+            <a:pPr algn="ctr"/>
+            <a:r>
+              <a:rPr lang="en-US" sz="700" i="1" dirty="0">
+                <a:solidFill>
+                  <a:srgbClr val="2E77AB"/>
+                </a:solidFill>
+                <a:latin typeface="Arial" panose="020B0604020202020204" pitchFamily="34" charset="0"/>
+                <a:cs typeface="Arial" panose="020B0604020202020204" pitchFamily="34" charset="0"/>
+              </a:rPr>
+              <a:t>p = 0.04</a:t>
+            </a:r>
+          </a:p>
+        </p:txBody>
+      </p:sp>
+      <p:sp>
+        <p:nvSpPr>
+          <p:cNvPr id="38" name="Rectangle 37">
+            <a:extLst>
+              <a:ext uri="{FF2B5EF4-FFF2-40B4-BE49-F238E27FC236}">
+                <a16:creationId xmlns:a16="http://schemas.microsoft.com/office/drawing/2014/main" id="{E785E38A-2EC7-5DA6-D59B-868DECA56F66}"/>
+              </a:ext>
+            </a:extLst>
+          </p:cNvPr>
+          <p:cNvSpPr/>
+          <p:nvPr/>
+        </p:nvSpPr>
+        <p:spPr>
+          <a:xfrm>
+            <a:off x="4553712" y="3090672"/>
+            <a:ext cx="636999" cy="144461"/>
+          </a:xfrm>
+          <a:prstGeom prst="rect">
+            <a:avLst/>
+          </a:prstGeom>
+          <a:noFill/>
+          <a:ln>
+            <a:noFill/>
+          </a:ln>
+          <a:effectLst>
+            <a:softEdge rad="0"/>
+          </a:effectLst>
+        </p:spPr>
+        <p:style>
+          <a:lnRef idx="2">
+            <a:schemeClr val="accent1">
+              <a:shade val="15000"/>
+            </a:schemeClr>
+          </a:lnRef>
+          <a:fillRef idx="1">
+            <a:schemeClr val="accent1"/>
+          </a:fillRef>
+          <a:effectRef idx="0">
+            <a:schemeClr val="accent1"/>
+          </a:effectRef>
+          <a:fontRef idx="minor">
+            <a:schemeClr val="lt1"/>
+          </a:fontRef>
+        </p:style>
+        <p:txBody>
+          <a:bodyPr lIns="0" rIns="0" rtlCol="0" anchor="ctr"/>
+          <a:lstStyle/>
+          <a:p>
+            <a:pPr algn="ctr"/>
+            <a:r>
+              <a:rPr lang="en-US" sz="700" i="1" dirty="0">
+                <a:solidFill>
+                  <a:srgbClr val="A97F2F"/>
+                </a:solidFill>
+                <a:latin typeface="Arial" panose="020B0604020202020204" pitchFamily="34" charset="0"/>
+                <a:cs typeface="Arial" panose="020B0604020202020204" pitchFamily="34" charset="0"/>
+              </a:rPr>
+              <a:t>p &lt; 0.01</a:t>
+            </a:r>
+          </a:p>
+        </p:txBody>
+      </p:sp>
+      <p:sp>
+        <p:nvSpPr>
+          <p:cNvPr id="39" name="Rectangle 38">
+            <a:extLst>
+              <a:ext uri="{FF2B5EF4-FFF2-40B4-BE49-F238E27FC236}">
+                <a16:creationId xmlns:a16="http://schemas.microsoft.com/office/drawing/2014/main" id="{4ADCFA41-24CB-4B62-5250-DEA51EB88B3A}"/>
+              </a:ext>
+            </a:extLst>
+          </p:cNvPr>
+          <p:cNvSpPr/>
+          <p:nvPr/>
+        </p:nvSpPr>
+        <p:spPr>
+          <a:xfrm>
+            <a:off x="3008376" y="4398264"/>
+            <a:ext cx="636999" cy="144461"/>
+          </a:xfrm>
+          <a:prstGeom prst="rect">
+            <a:avLst/>
+          </a:prstGeom>
+          <a:noFill/>
+          <a:ln>
+            <a:noFill/>
+          </a:ln>
+          <a:effectLst>
+            <a:softEdge rad="0"/>
+          </a:effectLst>
+        </p:spPr>
+        <p:style>
+          <a:lnRef idx="2">
+            <a:schemeClr val="accent1">
+              <a:shade val="15000"/>
+            </a:schemeClr>
+          </a:lnRef>
+          <a:fillRef idx="1">
+            <a:schemeClr val="accent1"/>
+          </a:fillRef>
+          <a:effectRef idx="0">
+            <a:schemeClr val="accent1"/>
+          </a:effectRef>
+          <a:fontRef idx="minor">
+            <a:schemeClr val="lt1"/>
+          </a:fontRef>
+        </p:style>
+        <p:txBody>
+          <a:bodyPr lIns="0" rIns="0" rtlCol="0" anchor="ctr"/>
+          <a:lstStyle/>
+          <a:p>
+            <a:pPr algn="ctr"/>
+            <a:r>
+              <a:rPr lang="en-US" sz="700" i="1" dirty="0">
+                <a:solidFill>
+                  <a:schemeClr val="tx1"/>
+                </a:solidFill>
+                <a:latin typeface="Arial" panose="020B0604020202020204" pitchFamily="34" charset="0"/>
+                <a:cs typeface="Arial" panose="020B0604020202020204" pitchFamily="34" charset="0"/>
+              </a:rPr>
+              <a:t>p = 0.02</a:t>
+            </a:r>
+          </a:p>
+        </p:txBody>
+      </p:sp>
+      <p:sp>
+        <p:nvSpPr>
+          <p:cNvPr id="47" name="Rectangle 46">
+            <a:extLst>
+              <a:ext uri="{FF2B5EF4-FFF2-40B4-BE49-F238E27FC236}">
+                <a16:creationId xmlns:a16="http://schemas.microsoft.com/office/drawing/2014/main" id="{BEB3E9F4-0F7B-28F8-051E-8A0ED629D4CB}"/>
+              </a:ext>
+            </a:extLst>
+          </p:cNvPr>
+          <p:cNvSpPr/>
+          <p:nvPr/>
+        </p:nvSpPr>
+        <p:spPr>
+          <a:xfrm>
+            <a:off x="4553712" y="4398264"/>
+            <a:ext cx="636999" cy="144461"/>
+          </a:xfrm>
+          <a:prstGeom prst="rect">
+            <a:avLst/>
+          </a:prstGeom>
+          <a:noFill/>
+          <a:ln>
+            <a:noFill/>
+          </a:ln>
+          <a:effectLst>
+            <a:softEdge rad="0"/>
+          </a:effectLst>
+        </p:spPr>
+        <p:style>
+          <a:lnRef idx="2">
+            <a:schemeClr val="accent1">
+              <a:shade val="15000"/>
+            </a:schemeClr>
+          </a:lnRef>
+          <a:fillRef idx="1">
+            <a:schemeClr val="accent1"/>
+          </a:fillRef>
+          <a:effectRef idx="0">
+            <a:schemeClr val="accent1"/>
+          </a:effectRef>
+          <a:fontRef idx="minor">
+            <a:schemeClr val="lt1"/>
+          </a:fontRef>
+        </p:style>
+        <p:txBody>
+          <a:bodyPr lIns="0" rIns="0" rtlCol="0" anchor="ctr"/>
+          <a:lstStyle/>
+          <a:p>
+            <a:pPr algn="ctr"/>
+            <a:r>
+              <a:rPr lang="en-US" sz="700" i="1" dirty="0">
+                <a:solidFill>
+                  <a:schemeClr val="tx1"/>
+                </a:solidFill>
+                <a:latin typeface="Arial" panose="020B0604020202020204" pitchFamily="34" charset="0"/>
+                <a:cs typeface="Arial" panose="020B0604020202020204" pitchFamily="34" charset="0"/>
+              </a:rPr>
+              <a:t>p = 0.02</a:t>
+            </a:r>
+          </a:p>
+        </p:txBody>
+      </p:sp>
       <p:pic>
         <p:nvPicPr>
           <p:cNvPr id="6" name="Picture 5" descr="A screenshot of a video game&#10;&#10;AI-generated content may be incorrect.">

</xml_diff>